<commit_message>
Deck: fix risk score/confidence to percentages, matching website
The pitch deck still showed the old 0-100 and 0-1 scales (94/100,
0.91 confidence, risk 97/100) after the website switched to
percentages. Updates build_deck.js and hand-patches the built
overseer-deck.pptx to match (Node wasn't available in this
environment to regenerate it from source).
</commit_message>
<xml_diff>
--- a/deck/overseer-deck.pptx
+++ b/deck/overseer-deck.pptx
@@ -3761,7 +3761,7 @@
                 <a:ea typeface="Courier New" pitchFamily="34" charset="-122"/>
                 <a:cs typeface="Courier New" pitchFamily="34" charset="-120"/>
               </a:rPr>
-              <a:t>$ verdict: risk 97/100  </a:t>
+              <a:t>$ verdict: risk 97%  </a:t>
             </a:r>
             <a:pPr indent="0" marL="0">
               <a:buNone/>
@@ -7596,7 +7596,7 @@
                 <a:ea typeface="Courier New" pitchFamily="34" charset="-122"/>
                 <a:cs typeface="Courier New" pitchFamily="34" charset="-120"/>
               </a:rPr>
-              <a:t>/100</a:t>
+              <a:t>%</a:t>
             </a:r>
             <a:endParaRPr lang="en-US" sz="1400" dirty="0"/>
           </a:p>
@@ -7674,7 +7674,7 @@
                 <a:ea typeface="Arial" pitchFamily="34" charset="-122"/>
                 <a:cs typeface="Arial" pitchFamily="34" charset="-120"/>
               </a:rPr>
-              <a:t>0.91</a:t>
+              <a:t>91%</a:t>
             </a:r>
             <a:endParaRPr lang="en-US" sz="1500" dirty="0"/>
           </a:p>

</xml_diff>